<commit_message>
Harmoniser la justification du seuil entre le notebook et la présentation
</commit_message>
<xml_diff>
--- a/Presentation.pptx
+++ b/Presentation.pptx
@@ -3829,7 +3829,7 @@
           <a:p>
             <a:r>
               <a:rPr lang="fr-FR" b="1" dirty="0"/>
-              <a:t>Seuil retenu : 0.551</a:t>
+              <a:t>Seuil retenu : 0.596</a:t>
             </a:r>
           </a:p>
           <a:p>
@@ -3848,50 +3848,6 @@
           </a:p>
           <a:p>
             <a:endParaRPr lang="fr-FR" dirty="0"/>
-          </a:p>
-          <a:p>
-            <a:r>
-              <a:rPr lang="fr-FR" b="1" dirty="0"/>
-              <a:t>Interprétation</a:t>
-            </a:r>
-          </a:p>
-          <a:p>
-            <a:r>
-              <a:rPr lang="fr-FR" b="1" dirty="0"/>
-              <a:t> 70 % des départs réels sont détectés</a:t>
-            </a:r>
-            <a:endParaRPr lang="fr-FR" dirty="0"/>
-          </a:p>
-          <a:p>
-            <a:r>
-              <a:rPr lang="fr-FR" dirty="0"/>
-              <a:t> </a:t>
-            </a:r>
-            <a:r>
-              <a:rPr lang="fr-FR" b="1" dirty="0"/>
-              <a:t>47 % des alertes sont correctes</a:t>
-            </a:r>
-            <a:r>
-              <a:rPr lang="fr-FR" dirty="0"/>
-              <a:t> (1 alerte sur 2 est un faux positif)</a:t>
-            </a:r>
-          </a:p>
-          <a:p>
-            <a:r>
-              <a:rPr lang="fr-FR" dirty="0"/>
-              <a:t> </a:t>
-            </a:r>
-            <a:r>
-              <a:rPr lang="fr-FR" b="1" dirty="0"/>
-              <a:t>F1 = 0.56</a:t>
-            </a:r>
-            <a:r>
-              <a:rPr lang="fr-FR" dirty="0"/>
-              <a:t> → bon compromis global pour un problème déséquilibré</a:t>
-            </a:r>
-          </a:p>
-          <a:p>
-            <a:endParaRPr lang="fr-FR" b="1" dirty="0"/>
           </a:p>
           <a:p>
             <a:r>
@@ -14714,9 +14670,9 @@
         <p:grpSpPr>
           <a:xfrm>
             <a:off x="570053" y="1046054"/>
-            <a:ext cx="9983164" cy="376128"/>
+            <a:ext cx="9983164" cy="1708160"/>
             <a:chOff x="570053" y="1046054"/>
-            <a:chExt cx="9983164" cy="376128"/>
+            <a:chExt cx="9983164" cy="1708160"/>
           </a:xfrm>
         </p:grpSpPr>
         <p:sp>
@@ -14734,7 +14690,7 @@
           <p:spPr>
             <a:xfrm>
               <a:off x="4459147" y="1046054"/>
-              <a:ext cx="6094070" cy="369332"/>
+              <a:ext cx="6094070" cy="1708160"/>
             </a:xfrm>
             <a:prstGeom prst="rect">
               <a:avLst/>
@@ -14767,6 +14723,40 @@
               <a:r>
                 <a:rPr lang="fr-FR" dirty="0"/>
                 <a:t>Ne joue quasiment aucun rôle dans le départ (:= 3 ou 4)</a:t>
+              </a:r>
+            </a:p>
+            <a:p>
+              <a:pPr algn="just"/>
+              <a:endParaRPr lang="fr-FR" dirty="0"/>
+            </a:p>
+            <a:p>
+              <a:pPr algn="just"/>
+              <a:r>
+                <a:rPr lang="fr-FR" dirty="0">
+                  <a:solidFill>
+                    <a:srgbClr val="FF0000"/>
+                  </a:solidFill>
+                </a:rPr>
+                <a:t>Risque de data-</a:t>
+              </a:r>
+              <a:r>
+                <a:rPr lang="fr-FR" dirty="0" err="1">
+                  <a:solidFill>
+                    <a:srgbClr val="FF0000"/>
+                  </a:solidFill>
+                </a:rPr>
+                <a:t>leakage</a:t>
+              </a:r>
+              <a:r>
+                <a:rPr lang="fr-FR" dirty="0"/>
+                <a:t>: l’information est potentiellement collectée après la décision du salarié de quitter l’entreprise.</a:t>
+              </a:r>
+            </a:p>
+            <a:p>
+              <a:pPr algn="just"/>
+              <a:r>
+                <a:rPr lang="fr-FR" dirty="0"/>
+                <a:t>Dans ce cas, elle introduit une fuite temporelle.</a:t>
               </a:r>
             </a:p>
           </p:txBody>
@@ -16410,7 +16400,7 @@
               <a:t>Recherche du seuil optimal (</a:t>
             </a:r>
             <a:r>
-              <a:rPr lang="fr-FR" sz="3600" kern="1200" noProof="0">
+              <a:rPr lang="fr-FR" sz="3600" kern="1200" noProof="0" dirty="0" err="1">
                 <a:ln w="0"/>
                 <a:solidFill>
                   <a:schemeClr val="accent1"/>
@@ -16424,22 +16414,25 @@
                 </a:effectLst>
                 <a:latin typeface="Aptos" panose="020B0004020202020204" pitchFamily="34" charset="0"/>
               </a:rPr>
-              <a:t>Recall)</a:t>
-            </a:r>
-            <a:endParaRPr lang="fr-FR" sz="3600" kern="1200" noProof="0" dirty="0">
-              <a:ln w="0"/>
-              <a:solidFill>
-                <a:schemeClr val="accent1"/>
-              </a:solidFill>
-              <a:effectLst>
-                <a:outerShdw blurRad="38100" dist="25400" dir="5400000" algn="ctr" rotWithShape="0">
-                  <a:srgbClr val="6E747A">
-                    <a:alpha val="43000"/>
-                  </a:srgbClr>
-                </a:outerShdw>
-              </a:effectLst>
-              <a:latin typeface="Aptos" panose="020B0004020202020204" pitchFamily="34" charset="0"/>
-            </a:endParaRPr>
+              <a:t>Recall</a:t>
+            </a:r>
+            <a:r>
+              <a:rPr lang="fr-FR" sz="3600" kern="1200" noProof="0" dirty="0">
+                <a:ln w="0"/>
+                <a:solidFill>
+                  <a:schemeClr val="accent1"/>
+                </a:solidFill>
+                <a:effectLst>
+                  <a:outerShdw blurRad="38100" dist="25400" dir="5400000" algn="ctr" rotWithShape="0">
+                    <a:srgbClr val="6E747A">
+                      <a:alpha val="43000"/>
+                    </a:srgbClr>
+                  </a:outerShdw>
+                </a:effectLst>
+                <a:latin typeface="Aptos" panose="020B0004020202020204" pitchFamily="34" charset="0"/>
+              </a:rPr>
+              <a:t>)</a:t>
+            </a:r>
           </a:p>
         </p:txBody>
       </p:sp>
@@ -17554,201 +17547,12 @@
           <a:chExt cx="0" cy="0"/>
         </a:xfrm>
       </p:grpSpPr>
-      <p:sp>
-        <p:nvSpPr>
-          <p:cNvPr id="2" name="Titre 1">
-            <a:extLst>
-              <a:ext uri="{FF2B5EF4-FFF2-40B4-BE49-F238E27FC236}">
-                <a16:creationId xmlns:a16="http://schemas.microsoft.com/office/drawing/2014/main" id="{FCFEA3B2-BE54-52C0-6847-FCA5F6024479}"/>
-              </a:ext>
-            </a:extLst>
-          </p:cNvPr>
-          <p:cNvSpPr>
-            <a:spLocks noGrp="1"/>
-          </p:cNvSpPr>
-          <p:nvPr>
-            <p:ph type="title"/>
-          </p:nvPr>
-        </p:nvSpPr>
-        <p:spPr/>
-        <p:txBody>
-          <a:bodyPr/>
-          <a:lstStyle/>
-          <a:p>
-            <a:r>
-              <a:rPr lang="fr-FR" b="1" dirty="0"/>
-              <a:t>La courbe Précision-Rappel</a:t>
-            </a:r>
-            <a:br>
-              <a:rPr lang="fr-FR" b="1" dirty="0"/>
-            </a:br>
-            <a:r>
-              <a:rPr lang="fr-FR" sz="1600" b="1" dirty="0"/>
-              <a:t>La courbe Précision-Rappel pour choisir le seuil</a:t>
-            </a:r>
-            <a:endParaRPr lang="fr-FR" dirty="0"/>
-          </a:p>
-        </p:txBody>
-      </p:sp>
-      <p:sp>
-        <p:nvSpPr>
-          <p:cNvPr id="22" name="ZoneTexte 21">
-            <a:extLst>
-              <a:ext uri="{FF2B5EF4-FFF2-40B4-BE49-F238E27FC236}">
-                <a16:creationId xmlns:a16="http://schemas.microsoft.com/office/drawing/2014/main" id="{AE6DC2BF-F3C2-29BD-BD7A-94120B4D0DC8}"/>
-              </a:ext>
-            </a:extLst>
-          </p:cNvPr>
-          <p:cNvSpPr txBox="1"/>
-          <p:nvPr/>
-        </p:nvSpPr>
-        <p:spPr>
-          <a:xfrm>
-            <a:off x="515185" y="5255689"/>
-            <a:ext cx="11161629" cy="1200329"/>
-          </a:xfrm>
-          <a:prstGeom prst="rect">
-            <a:avLst/>
-          </a:prstGeom>
-          <a:noFill/>
-        </p:spPr>
-        <p:txBody>
-          <a:bodyPr wrap="square">
-            <a:spAutoFit/>
-          </a:bodyPr>
-          <a:lstStyle/>
-          <a:p>
-            <a:pPr marL="285750" indent="-285750">
-              <a:buFont typeface="Arial" panose="020B0604020202020204" pitchFamily="34" charset="0"/>
-              <a:buChar char="•"/>
-            </a:pPr>
-            <a:r>
-              <a:rPr lang="fr-FR" sz="2400" b="1" dirty="0">
-                <a:latin typeface="Aptos" panose="020B0004020202020204" pitchFamily="34" charset="0"/>
-              </a:rPr>
-              <a:t>Rappel      = 70 % des départs réels sont détectés</a:t>
-            </a:r>
-          </a:p>
-          <a:p>
-            <a:pPr marL="285750" indent="-285750">
-              <a:buFont typeface="Arial" panose="020B0604020202020204" pitchFamily="34" charset="0"/>
-              <a:buChar char="•"/>
-            </a:pPr>
-            <a:r>
-              <a:rPr lang="fr-FR" sz="2400" b="1" dirty="0">
-                <a:latin typeface="Aptos" panose="020B0004020202020204" pitchFamily="34" charset="0"/>
-              </a:rPr>
-              <a:t>Précision = 47 % des alertes sont correctes</a:t>
-            </a:r>
-            <a:r>
-              <a:rPr lang="fr-FR" sz="2400" dirty="0">
-                <a:latin typeface="Aptos" panose="020B0004020202020204" pitchFamily="34" charset="0"/>
-              </a:rPr>
-              <a:t> (1 alerte sur 2 est un faux positif)</a:t>
-            </a:r>
-          </a:p>
-          <a:p>
-            <a:pPr marL="285750" indent="-285750">
-              <a:buFont typeface="Arial" panose="020B0604020202020204" pitchFamily="34" charset="0"/>
-              <a:buChar char="•"/>
-            </a:pPr>
-            <a:r>
-              <a:rPr lang="fr-FR" sz="2400" b="1" dirty="0">
-                <a:latin typeface="Aptos" panose="020B0004020202020204" pitchFamily="34" charset="0"/>
-              </a:rPr>
-              <a:t>F1-Score  = 0.56</a:t>
-            </a:r>
-            <a:r>
-              <a:rPr lang="fr-FR" sz="2400" dirty="0">
-                <a:latin typeface="Aptos" panose="020B0004020202020204" pitchFamily="34" charset="0"/>
-              </a:rPr>
-              <a:t> → bon compromis global pour un problème déséquilibré</a:t>
-            </a:r>
-          </a:p>
-        </p:txBody>
-      </p:sp>
-      <p:sp>
-        <p:nvSpPr>
-          <p:cNvPr id="23" name="ZoneTexte 22">
-            <a:extLst>
-              <a:ext uri="{FF2B5EF4-FFF2-40B4-BE49-F238E27FC236}">
-                <a16:creationId xmlns:a16="http://schemas.microsoft.com/office/drawing/2014/main" id="{8E183EA0-0E17-BEF6-8DBC-B1D027A117AF}"/>
-              </a:ext>
-            </a:extLst>
-          </p:cNvPr>
-          <p:cNvSpPr txBox="1"/>
-          <p:nvPr/>
-        </p:nvSpPr>
-        <p:spPr>
-          <a:xfrm>
-            <a:off x="419270" y="2685190"/>
-            <a:ext cx="4507831" cy="1692771"/>
-          </a:xfrm>
-          <a:prstGeom prst="rect">
-            <a:avLst/>
-          </a:prstGeom>
-          <a:noFill/>
-        </p:spPr>
-        <p:txBody>
-          <a:bodyPr wrap="square">
-            <a:spAutoFit/>
-          </a:bodyPr>
-          <a:lstStyle/>
-          <a:p>
-            <a:r>
-              <a:rPr lang="fr-FR" sz="3200" b="1" u="sng" dirty="0">
-                <a:solidFill>
-                  <a:srgbClr val="FF0000"/>
-                </a:solidFill>
-                <a:latin typeface="Aptos" panose="020B0004020202020204" pitchFamily="34" charset="0"/>
-              </a:rPr>
-              <a:t>Objectif :</a:t>
-            </a:r>
-          </a:p>
-          <a:p>
-            <a:pPr lvl="1"/>
-            <a:r>
-              <a:rPr lang="fr-FR" sz="3200" b="1" dirty="0">
-                <a:solidFill>
-                  <a:srgbClr val="FF0000"/>
-                </a:solidFill>
-                <a:latin typeface="Aptos" panose="020B0004020202020204" pitchFamily="34" charset="0"/>
-              </a:rPr>
-              <a:t>Détecter au moins </a:t>
-            </a:r>
-            <a:r>
-              <a:rPr lang="fr-FR" sz="4000" b="1" dirty="0">
-                <a:solidFill>
-                  <a:srgbClr val="FF0000"/>
-                </a:solidFill>
-                <a:latin typeface="Aptos" panose="020B0004020202020204" pitchFamily="34" charset="0"/>
-              </a:rPr>
-              <a:t>68%</a:t>
-            </a:r>
-            <a:r>
-              <a:rPr lang="fr-FR" sz="3200" b="1" dirty="0">
-                <a:solidFill>
-                  <a:srgbClr val="FF0000"/>
-                </a:solidFill>
-                <a:latin typeface="Aptos" panose="020B0004020202020204" pitchFamily="34" charset="0"/>
-              </a:rPr>
-              <a:t> des départs</a:t>
-            </a:r>
-            <a:endParaRPr lang="fr-FR" sz="3200" dirty="0">
-              <a:solidFill>
-                <a:srgbClr val="FF0000"/>
-              </a:solidFill>
-              <a:latin typeface="Aptos" panose="020B0004020202020204" pitchFamily="34" charset="0"/>
-            </a:endParaRPr>
-          </a:p>
-        </p:txBody>
-      </p:sp>
       <p:pic>
         <p:nvPicPr>
-          <p:cNvPr id="25" name="Image 24">
-            <a:extLst>
-              <a:ext uri="{FF2B5EF4-FFF2-40B4-BE49-F238E27FC236}">
-                <a16:creationId xmlns:a16="http://schemas.microsoft.com/office/drawing/2014/main" id="{389A54AB-07AD-7AAD-BAF7-030939333621}"/>
+          <p:cNvPr id="4" name="Image 3">
+            <a:extLst>
+              <a:ext uri="{FF2B5EF4-FFF2-40B4-BE49-F238E27FC236}">
+                <a16:creationId xmlns:a16="http://schemas.microsoft.com/office/drawing/2014/main" id="{B758F12A-C197-E267-6FED-A1152E66D549}"/>
               </a:ext>
             </a:extLst>
           </p:cNvPr>
@@ -17766,13 +17570,202 @@
         <p:spPr>
           <a:xfrm>
             <a:off x="5618747" y="1956561"/>
-            <a:ext cx="5678906" cy="3299128"/>
+            <a:ext cx="5705042" cy="3299128"/>
           </a:xfrm>
           <a:prstGeom prst="rect">
             <a:avLst/>
           </a:prstGeom>
         </p:spPr>
       </p:pic>
+      <p:sp>
+        <p:nvSpPr>
+          <p:cNvPr id="2" name="Titre 1">
+            <a:extLst>
+              <a:ext uri="{FF2B5EF4-FFF2-40B4-BE49-F238E27FC236}">
+                <a16:creationId xmlns:a16="http://schemas.microsoft.com/office/drawing/2014/main" id="{FCFEA3B2-BE54-52C0-6847-FCA5F6024479}"/>
+              </a:ext>
+            </a:extLst>
+          </p:cNvPr>
+          <p:cNvSpPr>
+            <a:spLocks noGrp="1"/>
+          </p:cNvSpPr>
+          <p:nvPr>
+            <p:ph type="title"/>
+          </p:nvPr>
+        </p:nvSpPr>
+        <p:spPr/>
+        <p:txBody>
+          <a:bodyPr/>
+          <a:lstStyle/>
+          <a:p>
+            <a:r>
+              <a:rPr lang="fr-FR" b="1" dirty="0"/>
+              <a:t>La courbe Précision-Rappel</a:t>
+            </a:r>
+            <a:br>
+              <a:rPr lang="fr-FR" b="1" dirty="0"/>
+            </a:br>
+            <a:r>
+              <a:rPr lang="fr-FR" sz="1600" b="1" dirty="0"/>
+              <a:t>La courbe Précision-Rappel pour choisir le seuil</a:t>
+            </a:r>
+            <a:endParaRPr lang="fr-FR" dirty="0"/>
+          </a:p>
+        </p:txBody>
+      </p:sp>
+      <p:sp>
+        <p:nvSpPr>
+          <p:cNvPr id="22" name="ZoneTexte 21">
+            <a:extLst>
+              <a:ext uri="{FF2B5EF4-FFF2-40B4-BE49-F238E27FC236}">
+                <a16:creationId xmlns:a16="http://schemas.microsoft.com/office/drawing/2014/main" id="{AE6DC2BF-F3C2-29BD-BD7A-94120B4D0DC8}"/>
+              </a:ext>
+            </a:extLst>
+          </p:cNvPr>
+          <p:cNvSpPr txBox="1"/>
+          <p:nvPr/>
+        </p:nvSpPr>
+        <p:spPr>
+          <a:xfrm>
+            <a:off x="515185" y="5255689"/>
+            <a:ext cx="11161629" cy="1200329"/>
+          </a:xfrm>
+          <a:prstGeom prst="rect">
+            <a:avLst/>
+          </a:prstGeom>
+          <a:noFill/>
+        </p:spPr>
+        <p:txBody>
+          <a:bodyPr wrap="square">
+            <a:spAutoFit/>
+          </a:bodyPr>
+          <a:lstStyle/>
+          <a:p>
+            <a:pPr marL="285750" indent="-285750">
+              <a:buFont typeface="Arial" panose="020B0604020202020204" pitchFamily="34" charset="0"/>
+              <a:buChar char="•"/>
+            </a:pPr>
+            <a:r>
+              <a:rPr lang="fr-FR" sz="2400" b="1" dirty="0">
+                <a:latin typeface="Aptos" panose="020B0004020202020204" pitchFamily="34" charset="0"/>
+              </a:rPr>
+              <a:t>Rappel      = 68 % des départs réels sont détectés</a:t>
+            </a:r>
+          </a:p>
+          <a:p>
+            <a:pPr marL="285750" indent="-285750">
+              <a:buFont typeface="Arial" panose="020B0604020202020204" pitchFamily="34" charset="0"/>
+              <a:buChar char="•"/>
+            </a:pPr>
+            <a:r>
+              <a:rPr lang="fr-FR" sz="2400" b="1" dirty="0">
+                <a:latin typeface="Aptos" panose="020B0004020202020204" pitchFamily="34" charset="0"/>
+              </a:rPr>
+              <a:t>Précision = 57 % des alertes sont correctes</a:t>
+            </a:r>
+            <a:r>
+              <a:rPr lang="fr-FR" sz="2400" dirty="0">
+                <a:latin typeface="Aptos" panose="020B0004020202020204" pitchFamily="34" charset="0"/>
+              </a:rPr>
+              <a:t> (1 alerte sur 2 est un faux positif)</a:t>
+            </a:r>
+          </a:p>
+          <a:p>
+            <a:pPr marL="285750" indent="-285750">
+              <a:buFont typeface="Arial" panose="020B0604020202020204" pitchFamily="34" charset="0"/>
+              <a:buChar char="•"/>
+            </a:pPr>
+            <a:r>
+              <a:rPr lang="fr-FR" sz="2400" b="1" dirty="0">
+                <a:latin typeface="Aptos" panose="020B0004020202020204" pitchFamily="34" charset="0"/>
+              </a:rPr>
+              <a:t>F1-Score  = 0.62</a:t>
+            </a:r>
+            <a:r>
+              <a:rPr lang="fr-FR" sz="2400" dirty="0">
+                <a:latin typeface="Aptos" panose="020B0004020202020204" pitchFamily="34" charset="0"/>
+              </a:rPr>
+              <a:t> → bon compromis global pour un problème déséquilibré</a:t>
+            </a:r>
+          </a:p>
+        </p:txBody>
+      </p:sp>
+      <p:sp>
+        <p:nvSpPr>
+          <p:cNvPr id="23" name="ZoneTexte 22">
+            <a:extLst>
+              <a:ext uri="{FF2B5EF4-FFF2-40B4-BE49-F238E27FC236}">
+                <a16:creationId xmlns:a16="http://schemas.microsoft.com/office/drawing/2014/main" id="{8E183EA0-0E17-BEF6-8DBC-B1D027A117AF}"/>
+              </a:ext>
+            </a:extLst>
+          </p:cNvPr>
+          <p:cNvSpPr txBox="1"/>
+          <p:nvPr/>
+        </p:nvSpPr>
+        <p:spPr>
+          <a:xfrm>
+            <a:off x="419270" y="2685190"/>
+            <a:ext cx="4507831" cy="1692771"/>
+          </a:xfrm>
+          <a:prstGeom prst="rect">
+            <a:avLst/>
+          </a:prstGeom>
+          <a:noFill/>
+        </p:spPr>
+        <p:txBody>
+          <a:bodyPr wrap="square">
+            <a:spAutoFit/>
+          </a:bodyPr>
+          <a:lstStyle/>
+          <a:p>
+            <a:r>
+              <a:rPr lang="fr-FR" sz="3200" b="1" u="sng" dirty="0">
+                <a:solidFill>
+                  <a:srgbClr val="FF0000"/>
+                </a:solidFill>
+                <a:latin typeface="Aptos" panose="020B0004020202020204" pitchFamily="34" charset="0"/>
+              </a:rPr>
+              <a:t>Objectif :</a:t>
+            </a:r>
+          </a:p>
+          <a:p>
+            <a:pPr lvl="1"/>
+            <a:r>
+              <a:rPr lang="fr-FR" sz="3200" b="1" dirty="0">
+                <a:solidFill>
+                  <a:srgbClr val="FF0000"/>
+                </a:solidFill>
+                <a:latin typeface="Aptos" panose="020B0004020202020204" pitchFamily="34" charset="0"/>
+              </a:rPr>
+              <a:t>Détecter au moins </a:t>
+            </a:r>
+            <a:r>
+              <a:rPr lang="fr-FR" sz="4000" b="1" dirty="0">
+                <a:solidFill>
+                  <a:srgbClr val="FF0000"/>
+                </a:solidFill>
+                <a:latin typeface="Aptos" panose="020B0004020202020204" pitchFamily="34" charset="0"/>
+              </a:rPr>
+              <a:t>68%</a:t>
+            </a:r>
+            <a:r>
+              <a:rPr lang="fr-FR" sz="3200" b="1" dirty="0">
+                <a:solidFill>
+                  <a:srgbClr val="FF0000"/>
+                </a:solidFill>
+                <a:latin typeface="Aptos" panose="020B0004020202020204" pitchFamily="34" charset="0"/>
+              </a:rPr>
+              <a:t> des départs</a:t>
+            </a:r>
+            <a:endParaRPr lang="fr-FR" sz="3200" dirty="0">
+              <a:solidFill>
+                <a:srgbClr val="FF0000"/>
+              </a:solidFill>
+              <a:latin typeface="Aptos" panose="020B0004020202020204" pitchFamily="34" charset="0"/>
+            </a:endParaRPr>
+          </a:p>
+        </p:txBody>
+      </p:sp>
     </p:spTree>
     <p:extLst>
       <p:ext uri="{BB962C8B-B14F-4D97-AF65-F5344CB8AC3E}">

</xml_diff>